<commit_message>
Fix errors and update presentation
</commit_message>
<xml_diff>
--- a/MarenzaSantarin_5min_Presentation_Capstone3.pptx
+++ b/MarenzaSantarin_5min_Presentation_Capstone3.pptx
@@ -15,7 +15,7 @@
     <p:sldId id="276" r:id="rId6"/>
     <p:sldId id="269" r:id="rId7"/>
     <p:sldId id="270" r:id="rId8"/>
-    <p:sldId id="271" r:id="rId9"/>
+    <p:sldId id="278" r:id="rId9"/>
     <p:sldId id="277" r:id="rId10"/>
   </p:sldIdLst>
   <p:sldSz cx="12192000" cy="6858000"/>
@@ -1033,90 +1033,6 @@
 </file>
 
 <file path=ppt/notesSlides/notesSlide5.xml><?xml version="1.0" encoding="utf-8"?>
-<p:notes xmlns:a="http://schemas.openxmlformats.org/drawingml/2006/main" xmlns:r="http://schemas.openxmlformats.org/officeDocument/2006/relationships" xmlns:p="http://schemas.openxmlformats.org/presentationml/2006/main">
-  <p:cSld>
-    <p:spTree>
-      <p:nvGrpSpPr>
-        <p:cNvPr id="1" name=""/>
-        <p:cNvGrpSpPr/>
-        <p:nvPr/>
-      </p:nvGrpSpPr>
-      <p:grpSpPr>
-        <a:xfrm>
-          <a:off x="0" y="0"/>
-          <a:ext cx="0" cy="0"/>
-          <a:chOff x="0" y="0"/>
-          <a:chExt cx="0" cy="0"/>
-        </a:xfrm>
-      </p:grpSpPr>
-      <p:sp>
-        <p:nvSpPr>
-          <p:cNvPr id="2" name="Slide Image Placeholder 1"/>
-          <p:cNvSpPr>
-            <a:spLocks noGrp="1" noRot="1" noChangeAspect="1"/>
-          </p:cNvSpPr>
-          <p:nvPr>
-            <p:ph type="sldImg"/>
-          </p:nvPr>
-        </p:nvSpPr>
-        <p:spPr/>
-      </p:sp>
-      <p:sp>
-        <p:nvSpPr>
-          <p:cNvPr id="3" name="Notes Placeholder 2"/>
-          <p:cNvSpPr>
-            <a:spLocks noGrp="1"/>
-          </p:cNvSpPr>
-          <p:nvPr>
-            <p:ph type="body" idx="1"/>
-          </p:nvPr>
-        </p:nvSpPr>
-        <p:spPr/>
-        <p:txBody>
-          <a:bodyPr/>
-          <a:lstStyle/>
-          <a:p>
-            <a:endParaRPr lang="en-US" dirty="0"/>
-          </a:p>
-        </p:txBody>
-      </p:sp>
-      <p:sp>
-        <p:nvSpPr>
-          <p:cNvPr id="4" name="Slide Number Placeholder 3"/>
-          <p:cNvSpPr>
-            <a:spLocks noGrp="1"/>
-          </p:cNvSpPr>
-          <p:nvPr>
-            <p:ph type="sldNum" sz="quarter" idx="5"/>
-          </p:nvPr>
-        </p:nvSpPr>
-        <p:spPr/>
-        <p:txBody>
-          <a:bodyPr/>
-          <a:lstStyle/>
-          <a:p>
-            <a:fld id="{0A3C37BE-C303-496D-B5CD-85F2937540FC}" type="slidenum">
-              <a:rPr lang="en-US" smtClean="0"/>
-              <a:t>5</a:t>
-            </a:fld>
-            <a:endParaRPr lang="en-US"/>
-          </a:p>
-        </p:txBody>
-      </p:sp>
-    </p:spTree>
-    <p:extLst>
-      <p:ext uri="{BB962C8B-B14F-4D97-AF65-F5344CB8AC3E}">
-        <p14:creationId xmlns:p14="http://schemas.microsoft.com/office/powerpoint/2010/main" val="1309799847"/>
-      </p:ext>
-    </p:extLst>
-  </p:cSld>
-  <p:clrMapOvr>
-    <a:masterClrMapping/>
-  </p:clrMapOvr>
-</p:notes>
-</file>
-
-<file path=ppt/notesSlides/notesSlide6.xml><?xml version="1.0" encoding="utf-8"?>
 <p:notes xmlns:a="http://schemas.openxmlformats.org/drawingml/2006/main" xmlns:r="http://schemas.openxmlformats.org/officeDocument/2006/relationships" xmlns:p="http://schemas.openxmlformats.org/presentationml/2006/main">
   <p:cSld>
     <p:spTree>
@@ -8997,8 +8913,8 @@
           <a:chExt cx="0" cy="0"/>
         </a:xfrm>
       </p:grpSpPr>
-      <mc:AlternateContent xmlns:mc="http://schemas.openxmlformats.org/markup-compatibility/2006" xmlns:we="http://schemas.microsoft.com/office/webextensions/webextension/2010/11" xmlns:pca="http://schemas.microsoft.com/office/powerpoint/2013/contentapp">
-        <mc:Choice Requires="we pca">
+      <mc:AlternateContent xmlns:mc="http://schemas.openxmlformats.org/markup-compatibility/2006">
+        <mc:Choice xmlns:we="http://schemas.microsoft.com/office/webextensions/webextension/2010/11" xmlns:pca="http://schemas.microsoft.com/office/powerpoint/2013/contentapp" Requires="we pca">
           <p:graphicFrame>
             <p:nvGraphicFramePr>
               <p:cNvPr id="2" name="Add-in" descr="Add-in content for Microsoft Power BI."/>
@@ -9018,7 +8934,7 @@
             </a:graphic>
           </p:graphicFrame>
         </mc:Choice>
-        <mc:Fallback xmlns="">
+        <mc:Fallback>
           <p:pic>
             <p:nvPicPr>
               <p:cNvPr id="2" name="Add-in" descr="Add-in content for Microsoft Power BI."/>
@@ -9083,38 +8999,56 @@
           <a:chExt cx="0" cy="0"/>
         </a:xfrm>
       </p:grpSpPr>
-      <mc:AlternateContent xmlns:mc="http://schemas.openxmlformats.org/markup-compatibility/2006" xmlns:we="http://schemas.microsoft.com/office/webextensions/webextension/2010/11" xmlns:pca="http://schemas.microsoft.com/office/powerpoint/2013/contentapp">
-        <mc:Choice Requires="we pca">
+      <mc:AlternateContent xmlns:mc="http://schemas.openxmlformats.org/markup-compatibility/2006">
+        <mc:Choice xmlns:we="http://schemas.microsoft.com/office/webextensions/webextension/2010/11" xmlns:pca="http://schemas.microsoft.com/office/powerpoint/2013/contentapp" Requires="we pca">
           <p:graphicFrame>
             <p:nvGraphicFramePr>
-              <p:cNvPr id="2" name="Add-in" descr="Add-in content for Microsoft Power BI."/>
+              <p:cNvPr id="2" name="Add-in 1" title="Microsoft Power BI">
+                <a:extLst>
+                  <a:ext uri="{FF2B5EF4-FFF2-40B4-BE49-F238E27FC236}">
+                    <a16:creationId xmlns:a16="http://schemas.microsoft.com/office/drawing/2014/main" id="{E482A17B-BEC9-CB58-A34C-018437BE7B5B}"/>
+                  </a:ext>
+                </a:extLst>
+              </p:cNvPr>
               <p:cNvGraphicFramePr>
                 <a:graphicFrameLocks noGrp="1"/>
               </p:cNvGraphicFramePr>
-              <p:nvPr/>
+              <p:nvPr>
+                <p:extLst>
+                  <p:ext uri="{D42A27DB-BD31-4B8C-83A1-F6EECF244321}">
+                    <p14:modId xmlns:p14="http://schemas.microsoft.com/office/powerpoint/2010/main" val="3155404013"/>
+                  </p:ext>
+                </p:extLst>
+              </p:nvPr>
             </p:nvGraphicFramePr>
             <p:xfrm>
               <a:off x="0" y="0"/>
-              <a:ext cx="12192000" cy="6857999"/>
+              <a:ext cx="12192000" cy="6858000"/>
             </p:xfrm>
             <a:graphic>
               <a:graphicData uri="http://schemas.microsoft.com/office/webextensions/webextension/2010/11">
-                <we:webextensionref xmlns:we="http://schemas.microsoft.com/office/webextensions/webextension/2010/11" xmlns:r="http://schemas.openxmlformats.org/officeDocument/2006/relationships" r:id="rId3"/>
+                <we:webextensionref xmlns:we="http://schemas.microsoft.com/office/webextensions/webextension/2010/11" xmlns:r="http://schemas.openxmlformats.org/officeDocument/2006/relationships" r:id="rId2"/>
               </a:graphicData>
             </a:graphic>
           </p:graphicFrame>
         </mc:Choice>
-        <mc:Fallback xmlns="">
+        <mc:Fallback>
           <p:pic>
             <p:nvPicPr>
-              <p:cNvPr id="2" name="Add-in" descr="Add-in content for Microsoft Power BI."/>
+              <p:cNvPr id="2" name="Add-in 1" title="Microsoft Power BI">
+                <a:extLst>
+                  <a:ext uri="{FF2B5EF4-FFF2-40B4-BE49-F238E27FC236}">
+                    <a16:creationId xmlns:a16="http://schemas.microsoft.com/office/drawing/2014/main" id="{E482A17B-BEC9-CB58-A34C-018437BE7B5B}"/>
+                  </a:ext>
+                </a:extLst>
+              </p:cNvPr>
               <p:cNvPicPr>
                 <a:picLocks noGrp="1" noRot="1" noChangeAspect="1" noMove="1" noResize="1" noEditPoints="1" noAdjustHandles="1" noChangeArrowheads="1" noChangeShapeType="1"/>
               </p:cNvPicPr>
               <p:nvPr/>
             </p:nvPicPr>
             <p:blipFill>
-              <a:blip r:embed="rId4"/>
+              <a:blip r:embed="rId3"/>
               <a:stretch>
                 <a:fillRect/>
               </a:stretch>
@@ -9122,7 +9056,7 @@
             <p:spPr>
               <a:xfrm>
                 <a:off x="0" y="0"/>
-                <a:ext cx="12192000" cy="6857999"/>
+                <a:ext cx="12192000" cy="6858000"/>
               </a:xfrm>
               <a:prstGeom prst="rect">
                 <a:avLst/>
@@ -9134,7 +9068,7 @@
     </p:spTree>
     <p:extLst>
       <p:ext uri="{BB962C8B-B14F-4D97-AF65-F5344CB8AC3E}">
-        <p14:creationId xmlns:p14="http://schemas.microsoft.com/office/powerpoint/2010/main" val="1378148827"/>
+        <p14:creationId xmlns:p14="http://schemas.microsoft.com/office/powerpoint/2010/main" val="4195084065"/>
       </p:ext>
     </p:extLst>
   </p:cSld>
@@ -9143,10 +9077,14 @@
   </p:clrMapOvr>
   <mc:AlternateContent xmlns:mc="http://schemas.openxmlformats.org/markup-compatibility/2006" xmlns:p14="http://schemas.microsoft.com/office/powerpoint/2010/main">
     <mc:Choice Requires="p14">
-      <p:transition p14:dur="0"/>
+      <p:transition spd="med" p14:dur="700">
+        <p:fade/>
+      </p:transition>
     </mc:Choice>
     <mc:Fallback xmlns="">
-      <p:transition/>
+      <p:transition spd="med">
+        <p:fade/>
+      </p:transition>
     </mc:Fallback>
   </mc:AlternateContent>
 </p:sld>
@@ -10188,28 +10126,29 @@
 </file>
 
 <file path=ppt/webextensions/webextension3.xml><?xml version="1.0" encoding="utf-8"?>
-<we:webextension xmlns:we="http://schemas.microsoft.com/office/webextensions/webextension/2010/11" id="{5bc84c9b-4570-4cc5-a805-0dc67b135b2c}">
-  <we:reference id="WA200003233" version="2.0.0.3" store="en-US" storeType="OMEX"/>
-  <we:alternateReferences/>
+<we:webextension xmlns:we="http://schemas.microsoft.com/office/webextensions/webextension/2010/11" id="{3233F11C-4A8E-4F43-81E0-304BE8CAC748}">
+  <we:reference id="wa200003233" version="2.0.0.3" store="en-US" storeType="OMEX"/>
+  <we:alternateReferences>
+    <we:reference id="WA200003233" version="2.0.0.3" store="WA200003233" storeType="OMEX"/>
+  </we:alternateReferences>
   <we:properties>
-    <we:property name="Microsoft.Office.CampaignId" value="&quot;none&quot;"/>
-    <we:property name="artifactViewState" value="&quot;live&quot;"/>
+    <we:property name="embedUrl" value="&quot;/reportEmbed?reportId=6e11bdef-cbab-4cde-83d2-d7a4e260bf6f&amp;config=eyJjbHVzdGVyVXJsIjoiaHR0cHM6Ly9XQUJJLVdFU1QtVVMtRS1QUklNQVJZLXJlZGlyZWN0LmFuYWx5c2lzLndpbmRvd3MubmV0IiwiZW1iZWRGZWF0dXJlcyI6eyJ1c2FnZU1ldHJpY3NWTmV4dCI6dHJ1ZX19&amp;disableSensitivityBanner=true&amp;storytellingChangeViewModeShortcutKeys=true&quot;"/>
+    <we:property name="bookmark" value="&quot;H4sIAAAAAAAAA91YTW/jNhD9K4aA3oyC4odI5tZ499YWQR0sUBQ5DMmxV7uKZFB0ajfwf+9Q8n7ECYJi26KqThZn6Jn33pASOY9FqPtdA8ef4R6Lq+K66z7eQ/y4KItl0Y42p4W0LmhpjGfKseC9IG+3S3XX9sXVY5EgbjG9q/s9NDkQGX+7WxbQNDewzaMNND0uix3Gvmuhqf/AcTK5UtzjaVngYdd0EXLIdYKEOewDTacxQSi/zxnBp/oB1+jTaFUeudxsLK9Q88pyLzWnaf04YUD24pQceki/6toEdUtpsg2FNIxrMB6Z14ZzECzb+7rdNmfAX/57e9xlcRIekusOWQ/3gRLnSKcTERLa6pJJZCi1KUWlFR+ibeomnRO649vDLpJWpOAY7YfwAK3HUAyCROxH/o/FTwj9Pg6qvH3iWHf76PEX3AyuNtXpSHHWqYu4WEND4mcwN7Ej7QfXbZeg+cr1vvt9FZEUD8UVO92R5VW+HmI4u55QpkEMGK+PA503dfxUJb68QPxvUSHs5DZQMmulNJqhrRirGOopyM4ZV/NQ/QmTUXSlNZcVd8yAqUoHAugNMQ3R5WxElxei+9Jq57gJYIJHBYwJPxHRxWxEFxeiW8aU9opL7Y1SrnKiMhMRnc9GdH4puteu1AqVtpaJylvOJrbSF6v30G5xBto/IzSWQPgQPHMV99w4JsCychKnmWeIF9/NrggDpfM7X4UKdIkMkB4qxYyYShnk3HbCM0Lnsw53ZbBCGePQWRqIMLGzzpx2wguUxjI4E1jQXGsWrFXB0WeZT6QMam474Rmh81WLb+jcXzlLN9uyZIw+EFN5Gan57YQXKJ13glOiFCVIWQW6hQVL17BvL8Oqa/b37V+F/IbUXNyCa/AS8a8I8QXVl58RrMi07WLtB33/DohXdDsnOb6K5H/QdGn2PdUSwzVEqn9M//2KvOy9fOrO0ZQPX/XfPhcgI/uH19bd0GezskRa+pJbAOOCpDNRmeN8S9duCPjFUtxj3A5idfvU78DjDbQ4UNmNaGocO4eHHbQhF3N4jvn3x5oqNqZ+B80+Zx26oMWQJmM//QmJjPvQfRUAAA==&quot;"/>
+    <we:property name="datasetId" value="&quot;9ad6c4c5-df19-41c4-a070-309b27842964&quot;"/>
+    <we:property name="pageName" value="&quot;5ce24ff926e72692c472&quot;"/>
+    <we:property name="reportUrl" value="&quot;/links/QLgz1FHjk6?ctid=bbce5c37-f181-4d0c-9310-7f877336e1cf&amp;bookmarkGuid=54506382-e201-40d9-aa8b-9143abb1219c&quot;"/>
+    <we:property name="reportName" value="&quot;Santarin_capstone3&quot;"/>
+    <we:property name="reportState" value="&quot;CONNECTED&quot;"/>
+    <we:property name="pageDisplayName" value="&quot;Insight Summary&quot;"/>
     <we:property name="backgroundColor" value="&quot;#FFFFFF&quot;"/>
-    <we:property name="bookmark" value="&quot;H4sIAAAAAAAAA91YwW7bOBD9FUPA3oyCIkVRzC1xc2rTBnVQoFgEiyE5dtUqkkHRWXsD//sOJXXTOEGwSFtU0MniDD3z3htSIucucWW7qWD/Dm4wOUnOmubrDfivszSZJ/Vge//+zcXphzd/vTu9OCdzswllU7fJyV0SwK8xfCzbLVQxAhn/vJ4nUFWXsI6jFVQtzpMN+rapoSr/wX4yuYLf4mGe4G5TNR5iyGWAgDHsLU2nMeVOXwnKCDaUt7hEG3qrtMiz1UrzHBXPNbeZ4jSt7Sd0yJ6cEkN36RdNHaCsKU20ocgKxhUUFplVBecgWLS3Zb2uBsD3/73ab6IqAXfBNLuoh/lCiWOkw4EICaVVyjJkmKkiFbmSvIu2KqswJDT7893Gk1akYB/t1N1CbdElnSAe257/XXKB0G59p8r5A8ey2XqLH3DVuepQhj3FWYbG42wJFYkfwVz6hrTvXFdNgOo71+fm74VHUtwlJ+xwTZZn+VrwbnA9oEwD79Cf7Ts6r0v/rUp8foT4V1Eh7OQuIGVaZ1mhGOqcsZyhGoPsnHE5DdUfMOlFl0rxLOeGFVDkqQEBVoxE9GwyomdHottUK2N44aBwFiUwJuxIRBeTEV0cia4Zk8pKnilbSGlyI/JiJKLzyYjOj0W3yqRKolRaM5FbzdnIVvps8RnqNU5A+0eE+hII65xlJueWF4YJ0CwdxWnmEeLZH5MrQkdpeOdLl4NKkQHSQy5ZIcZShmxqO+ERoeGsw03qtJBFYdBoGgg3srPOlHbCE5T6MpjCMae4UsxpLZ2hzzIfSRnk1HbCI0LDVYuv6NyfG0032zRljD4QY3kZyenthCcoDTvBSJGKFLIsd3QLc5quYS8vw6Kptjf1/4X8mtScXYGp8BjxJwT/hOrz8bQ67qEsyLRufGm7Uv+IHs+AGZLsX7QUq21LtUR3Bp7q78PvX5HHvZdv3Tma8uW7/tt/rCOyn7y2rrs+m85SpKWfcQ1QGJfRmSiNcV7StesC3luSG/TrTqxmG9oNWLyEGjsqmx5NiX3ncLeB2sVids8+/r4tqWJ96o9QbWPWrguadEkITRmZPf+H2BtNOliR6+FfZHkZOKYVAAA=&quot;"/>
-    <we:property name="creatorSessionId" value="&quot;451d93ba-eb5a-4c61-96ef-c1a52c3b2d5a&quot;"/>
+    <we:property name="initialStateBookmark" value="&quot;H4sIAAAAAAAAA91Y32/bNhD+VwwBezMGihRFMW+Jm6cubVAHBYohGI7k2VWrSAJFZ/YC/+87SuqPOEEwdBum6cniHX33fd+REnkPiSu7toLDG7jD5Cy5aJrPd+A/L9JkmdSj7e3b11fn717/9ub86pLMTRvKpu6Ss4ckgN9ieF92O6hiBDL+ertMoKquYRtHG6g6XCYt+q6poSr/wGEyuYLf4XGZ4L6tGg8x5DpAwBj2nqbTmHKnPwvKCDaU97hGGwartMizzUbzHBXPNbeZ4jStGyb0yJ6dEkP36VdNHaCsKU20ocgKxhUUFplVBecgWLR3Zb2tRsDf/ntzaKMqAffBNPuoh/lEiWOk45EICaVVyjJkmKkiFbmSvI+2KaswJjSHy33rSStScIh27u6htuiSXhCP3cD/IblC6Ha+V+XykWPd7LzFd7jpXXUow4HirEPjcbGGisSPYK59Q9r3rpsmQPWd62Pz+8ojKe6SM3a8JcuLfC14N7oeUaaBd+gvDj2dV6X/UiW+PEH8b1Eh7OQuIGVaZ1mhGOqcsZyhmoLsnHE5D9UfMRlEl0rxLOeGFVDkqQEBVkxE9Gw2omcnottUK2N44aBwFiUwJuxERBezEV2ciK4Zk8pKnilbSGlyI/JiIqLz2YjOT0W3yqRKolRaM5FbzdnEVvpi9RHqLc5A+yeEhhII65xlJueWF4YJ0CydxGnmCeLFT7MrQk9pfOdLl4NKkQHSQy5ZIaZShmxuO+EJofGsw03qtJBFYdBoGgg3sbPOnHbCM5SGMpjCMae4UsxpLZ2hzzKfSBnk3HbCE0LjVYtv6NyfG0032zRljD4QU3kZyfnthGcojTvBSJGKFLIsd3QLc5quYT9ehlVT7e7qvwr5Fam5uAFT4SniDwj+GdWXXxGsyLRtfGl7ff8OiBd0G5McXkTyP2i6VLuOaonuAjzV34f/fkWe9l6+dOdoyqfv+m9fCxCR/cNr67bvs+ksRVr6GdcAhXEZnYnSGOdHunZ9wG+W5A79ther2YWuBYvXUGNPpR3QlDh0Dvct1C4Ws3/28feXkio2pH4P1S5m7bugSZ+E0JSR2ct/iL3RpIcVuR7/BMo6a1SmFQAA&quot;"/>
+    <we:property name="isFiltersActionButtonVisible" value="true"/>
+    <we:property name="isVisualContainerHeaderHidden" value="false"/>
+    <we:property name="reportEmbeddedTime" value="&quot;2026-06-26T01:50:44.794Z&quot;"/>
     <we:property name="creatorTenantId" value="&quot;bbce5c37-f181-4d0c-9310-7f877336e1cf&quot;"/>
     <we:property name="creatorUserId" value="&quot;10032005A84173F9&quot;"/>
-    <we:property name="datasetId" value="&quot;9ad6c4c5-df19-41c4-a070-309b27842964&quot;"/>
-    <we:property name="embedUrl" value="&quot;/reportEmbed?reportId=6e11bdef-cbab-4cde-83d2-d7a4e260bf6f&amp;config=eyJjbHVzdGVyVXJsIjoiaHR0cHM6Ly9XQUJJLVdFU1QtVVMtRS1QUklNQVJZLXJlZGlyZWN0LmFuYWx5c2lzLndpbmRvd3MubmV0IiwiZW1iZWRGZWF0dXJlcyI6eyJ1c2FnZU1ldHJpY3NWTmV4dCI6dHJ1ZX19&amp;disableSensitivityBanner=true&amp;storytellingChangeViewModeShortcutKeys=true&quot;"/>
-    <we:property name="initialStateBookmark" value="&quot;H4sIAAAAAAAAA91YwW7bOBD9FUPA3oyCIkVRzC1xc2rTBnVQoFgEiyE5dtUqkkHRWXsD//sOJXXTOEGwSFtU0MniDD3z3htSIucucWW7qWD/Dm4wOUnOmubrDfivszSZJ/Vge//+zcXphzd/vTu9OCdzswllU7fJyV0SwK8xfCzbLVQxAhn/vJ4nUFWXsI6jFVQtzpMN+rapoSr/wX4yuYLf4mGe4G5TNR5iyGWAgDHsLU2nMeVOXwnKCDaUt7hEG3qrtMiz1UrzHBXPNbeZ4jSt7Sd0yJ6cEkN36RdNHaCsKU20ocgKxhUUFplVBecgWLS3Zb2uBsD3/73ab6IqAXfBNLuoh/lCiWOkw4EICaVVyjJkmKkiFbmSvIu2KqswJDT7893Gk1akYB/t1N1CbdElnSAe257/XXKB0G59p8r5A8ey2XqLH3DVuepQhj3FWYbG42wJFYkfwVz6hrTvXFdNgOo71+fm74VHUtwlJ+xwTZZn+VrwbnA9oEwD79Cf7Ts6r0v/rUp8foT4V1Eh7OQuIGVaZ1mhGOqcsZyhGoPsnHE5DdUfMOlFl0rxLOeGFVDkqQEBVoxE9GwyomdHottUK2N44aBwFiUwJuxIRBeTEV0cia4Zk8pKnilbSGlyI/JiJKLzyYjOj0W3yqRKolRaM5FbzdnIVvps8RnqNU5A+0eE+hII65xlJueWF4YJ0CwdxWnmEeLZH5MrQkdpeOdLl4NKkQHSQy5ZIcZShmxqO+ERoeGsw03qtJBFYdBoGgg3srPOlHbCE5T6MpjCMae4UsxpLZ2hzzIfSRnk1HbCI0LDVYuv6NyfG0032zRljD4QY3kZyenthCcoDTvBSJGKFLIsd3QLc5quYS8vw6Kptjf1/4X8mtScXYGp8BjxJwT/hOrz8bQ67qEsyLRufGm7Uv+IHs+AGZLsX7QUq21LtUR3Bp7q78PvX5HHvZdv3Tma8uW7/tt/rCOyn7y2rrs+m85SpKWfcQ1QGJfRmSiNcV7StesC3luSG/TrTqxmG9oNWLyEGjsqmx5NiX3ncLeB2sVids8+/r4tqWJ96o9QbWPWrguadEkITRmZPf+H2BtNOliR6+FfZHkZOKYVAAA=&quot;"/>
-    <we:property name="isFiltersActionButtonVisible" value="true"/>
-    <we:property name="isVisualContainerHeaderHidden" value="false"/>
-    <we:property name="pageDisplayName" value="&quot;Insight Summary&quot;"/>
-    <we:property name="pageName" value="&quot;5ce24ff926e72692c472&quot;"/>
-    <we:property name="reportEmbeddedTime" value="&quot;2026-06-23T22:31:44.009Z&quot;"/>
-    <we:property name="reportName" value="&quot;Santarin_capstone3&quot;"/>
-    <we:property name="reportState" value="&quot;CONNECTED&quot;"/>
-    <we:property name="reportUrl" value="&quot;/groups/me/reports/6e11bdef-cbab-4cde-83d2-d7a4e260bf6f/5ce24ff926e72692c472?bookmarkGuid=5366ef6d-b297-4234-a36f-bd5b118ea755&amp;bookmarkUsage=1&amp;ctid=bbce5c37-f181-4d0c-9310-7f877336e1cf&amp;fromEntryPoint=export&quot;"/>
+    <we:property name="creatorSessionId" value="&quot;48fcb2f2-58e6-47b5-9a26-bca1b358ee46&quot;"/>
+    <we:property name="artifactViewState" value="&quot;live&quot;"/>
   </we:properties>
   <we:bindings/>
   <we:snapshot xmlns:r="http://schemas.openxmlformats.org/officeDocument/2006/relationships"/>
@@ -10217,141 +10156,6 @@
 </file>
 
 <file path=customXml/item1.xml><?xml version="1.0" encoding="utf-8"?>
-<?mso-contentType ?>
-<FormTemplates xmlns="http://schemas.microsoft.com/sharepoint/v3/contenttype/forms">
-  <Display>DocumentLibraryForm</Display>
-  <Edit>AssetEditForm</Edit>
-  <New>DocumentLibraryForm</New>
-</FormTemplates>
-</file>
-
-<file path=customXml/item2.xml><?xml version="1.0" encoding="utf-8"?>
-<p:properties xmlns:p="http://schemas.microsoft.com/office/2006/metadata/properties" xmlns:xsi="http://www.w3.org/2001/XMLSchema-instance" xmlns:pc="http://schemas.microsoft.com/office/infopath/2007/PartnerControls">
-  <documentManagement>
-    <APDescription xmlns="4873beb7-5857-4685-be1f-d57550cc96cc" xsi:nil="true"/>
-    <AssetExpire xmlns="4873beb7-5857-4685-be1f-d57550cc96cc">2029-01-01T08:00:00+00:00</AssetExpire>
-    <CampaignTagsTaxHTField0 xmlns="4873beb7-5857-4685-be1f-d57550cc96cc">
-      <Terms xmlns="http://schemas.microsoft.com/office/infopath/2007/PartnerControls"/>
-    </CampaignTagsTaxHTField0>
-    <IntlLangReviewDate xmlns="4873beb7-5857-4685-be1f-d57550cc96cc" xsi:nil="true"/>
-    <TPFriendlyName xmlns="4873beb7-5857-4685-be1f-d57550cc96cc" xsi:nil="true"/>
-    <IntlLangReview xmlns="4873beb7-5857-4685-be1f-d57550cc96cc">false</IntlLangReview>
-    <LocLastLocAttemptVersionLookup xmlns="4873beb7-5857-4685-be1f-d57550cc96cc">855024</LocLastLocAttemptVersionLookup>
-    <PolicheckWords xmlns="4873beb7-5857-4685-be1f-d57550cc96cc" xsi:nil="true"/>
-    <SubmitterId xmlns="4873beb7-5857-4685-be1f-d57550cc96cc" xsi:nil="true"/>
-    <AcquiredFrom xmlns="4873beb7-5857-4685-be1f-d57550cc96cc">Internal MS</AcquiredFrom>
-    <EditorialStatus xmlns="4873beb7-5857-4685-be1f-d57550cc96cc">Complete</EditorialStatus>
-    <Markets xmlns="4873beb7-5857-4685-be1f-d57550cc96cc"/>
-    <OriginAsset xmlns="4873beb7-5857-4685-be1f-d57550cc96cc" xsi:nil="true"/>
-    <AssetStart xmlns="4873beb7-5857-4685-be1f-d57550cc96cc">2012-08-31T08:50:00+00:00</AssetStart>
-    <FriendlyTitle xmlns="4873beb7-5857-4685-be1f-d57550cc96cc" xsi:nil="true"/>
-    <MarketSpecific xmlns="4873beb7-5857-4685-be1f-d57550cc96cc">false</MarketSpecific>
-    <TPNamespace xmlns="4873beb7-5857-4685-be1f-d57550cc96cc" xsi:nil="true"/>
-    <PublishStatusLookup xmlns="4873beb7-5857-4685-be1f-d57550cc96cc">
-      <Value>1616423</Value>
-    </PublishStatusLookup>
-    <APAuthor xmlns="4873beb7-5857-4685-be1f-d57550cc96cc">
-      <UserInfo>
-        <DisplayName>REDMOND\kristaa</DisplayName>
-        <AccountId>136</AccountId>
-        <AccountType/>
-      </UserInfo>
-    </APAuthor>
-    <TPCommandLine xmlns="4873beb7-5857-4685-be1f-d57550cc96cc" xsi:nil="true"/>
-    <IntlLangReviewer xmlns="4873beb7-5857-4685-be1f-d57550cc96cc" xsi:nil="true"/>
-    <OpenTemplate xmlns="4873beb7-5857-4685-be1f-d57550cc96cc">true</OpenTemplate>
-    <CSXSubmissionDate xmlns="4873beb7-5857-4685-be1f-d57550cc96cc" xsi:nil="true"/>
-    <TaxCatchAll xmlns="4873beb7-5857-4685-be1f-d57550cc96cc"/>
-    <Manager xmlns="4873beb7-5857-4685-be1f-d57550cc96cc" xsi:nil="true"/>
-    <NumericId xmlns="4873beb7-5857-4685-be1f-d57550cc96cc" xsi:nil="true"/>
-    <ParentAssetId xmlns="4873beb7-5857-4685-be1f-d57550cc96cc" xsi:nil="true"/>
-    <OriginalSourceMarket xmlns="4873beb7-5857-4685-be1f-d57550cc96cc" xsi:nil="true"/>
-    <ApprovalStatus xmlns="4873beb7-5857-4685-be1f-d57550cc96cc">InProgress</ApprovalStatus>
-    <TPComponent xmlns="4873beb7-5857-4685-be1f-d57550cc96cc" xsi:nil="true"/>
-    <EditorialTags xmlns="4873beb7-5857-4685-be1f-d57550cc96cc" xsi:nil="true"/>
-    <TPExecutable xmlns="4873beb7-5857-4685-be1f-d57550cc96cc" xsi:nil="true"/>
-    <TPLaunchHelpLink xmlns="4873beb7-5857-4685-be1f-d57550cc96cc" xsi:nil="true"/>
-    <LocComments xmlns="4873beb7-5857-4685-be1f-d57550cc96cc" xsi:nil="true"/>
-    <LocRecommendedHandoff xmlns="4873beb7-5857-4685-be1f-d57550cc96cc" xsi:nil="true"/>
-    <SourceTitle xmlns="4873beb7-5857-4685-be1f-d57550cc96cc" xsi:nil="true"/>
-    <CSXUpdate xmlns="4873beb7-5857-4685-be1f-d57550cc96cc">false</CSXUpdate>
-    <IntlLocPriority xmlns="4873beb7-5857-4685-be1f-d57550cc96cc" xsi:nil="true"/>
-    <UAProjectedTotalWords xmlns="4873beb7-5857-4685-be1f-d57550cc96cc" xsi:nil="true"/>
-    <AssetType xmlns="4873beb7-5857-4685-be1f-d57550cc96cc">TP</AssetType>
-    <MachineTranslated xmlns="4873beb7-5857-4685-be1f-d57550cc96cc">false</MachineTranslated>
-    <OutputCachingOn xmlns="4873beb7-5857-4685-be1f-d57550cc96cc">false</OutputCachingOn>
-    <TemplateStatus xmlns="4873beb7-5857-4685-be1f-d57550cc96cc">Complete</TemplateStatus>
-    <IsSearchable xmlns="4873beb7-5857-4685-be1f-d57550cc96cc">true</IsSearchable>
-    <ContentItem xmlns="4873beb7-5857-4685-be1f-d57550cc96cc" xsi:nil="true"/>
-    <HandoffToMSDN xmlns="4873beb7-5857-4685-be1f-d57550cc96cc" xsi:nil="true"/>
-    <ShowIn xmlns="4873beb7-5857-4685-be1f-d57550cc96cc">Show everywhere</ShowIn>
-    <ThumbnailAssetId xmlns="4873beb7-5857-4685-be1f-d57550cc96cc" xsi:nil="true"/>
-    <UALocComments xmlns="4873beb7-5857-4685-be1f-d57550cc96cc" xsi:nil="true"/>
-    <UALocRecommendation xmlns="4873beb7-5857-4685-be1f-d57550cc96cc">Localize</UALocRecommendation>
-    <LastModifiedDateTime xmlns="4873beb7-5857-4685-be1f-d57550cc96cc" xsi:nil="true"/>
-    <LegacyData xmlns="4873beb7-5857-4685-be1f-d57550cc96cc" xsi:nil="true"/>
-    <LocManualTestRequired xmlns="4873beb7-5857-4685-be1f-d57550cc96cc">false</LocManualTestRequired>
-    <LocMarketGroupTiers2 xmlns="4873beb7-5857-4685-be1f-d57550cc96cc" xsi:nil="true"/>
-    <ClipArtFilename xmlns="4873beb7-5857-4685-be1f-d57550cc96cc" xsi:nil="true"/>
-    <TPApplication xmlns="4873beb7-5857-4685-be1f-d57550cc96cc" xsi:nil="true"/>
-    <CSXHash xmlns="4873beb7-5857-4685-be1f-d57550cc96cc" xsi:nil="true"/>
-    <DirectSourceMarket xmlns="4873beb7-5857-4685-be1f-d57550cc96cc" xsi:nil="true"/>
-    <PrimaryImageGen xmlns="4873beb7-5857-4685-be1f-d57550cc96cc">true</PrimaryImageGen>
-    <PlannedPubDate xmlns="4873beb7-5857-4685-be1f-d57550cc96cc" xsi:nil="true"/>
-    <CSXSubmissionMarket xmlns="4873beb7-5857-4685-be1f-d57550cc96cc" xsi:nil="true"/>
-    <Downloads xmlns="4873beb7-5857-4685-be1f-d57550cc96cc">0</Downloads>
-    <ArtSampleDocs xmlns="4873beb7-5857-4685-be1f-d57550cc96cc" xsi:nil="true"/>
-    <TrustLevel xmlns="4873beb7-5857-4685-be1f-d57550cc96cc">1 Microsoft Managed Content</TrustLevel>
-    <BlockPublish xmlns="4873beb7-5857-4685-be1f-d57550cc96cc">false</BlockPublish>
-    <TPLaunchHelpLinkType xmlns="4873beb7-5857-4685-be1f-d57550cc96cc">Template</TPLaunchHelpLinkType>
-    <LocalizationTagsTaxHTField0 xmlns="4873beb7-5857-4685-be1f-d57550cc96cc">
-      <Terms xmlns="http://schemas.microsoft.com/office/infopath/2007/PartnerControls"/>
-    </LocalizationTagsTaxHTField0>
-    <BusinessGroup xmlns="4873beb7-5857-4685-be1f-d57550cc96cc" xsi:nil="true"/>
-    <Providers xmlns="4873beb7-5857-4685-be1f-d57550cc96cc" xsi:nil="true"/>
-    <TemplateTemplateType xmlns="4873beb7-5857-4685-be1f-d57550cc96cc">PowerPoint Presentation Template</TemplateTemplateType>
-    <TimesCloned xmlns="4873beb7-5857-4685-be1f-d57550cc96cc" xsi:nil="true"/>
-    <TPAppVersion xmlns="4873beb7-5857-4685-be1f-d57550cc96cc" xsi:nil="true"/>
-    <VoteCount xmlns="4873beb7-5857-4685-be1f-d57550cc96cc" xsi:nil="true"/>
-    <AverageRating xmlns="4873beb7-5857-4685-be1f-d57550cc96cc" xsi:nil="true"/>
-    <FeatureTagsTaxHTField0 xmlns="4873beb7-5857-4685-be1f-d57550cc96cc">
-      <Terms xmlns="http://schemas.microsoft.com/office/infopath/2007/PartnerControls"/>
-    </FeatureTagsTaxHTField0>
-    <Provider xmlns="4873beb7-5857-4685-be1f-d57550cc96cc" xsi:nil="true"/>
-    <UACurrentWords xmlns="4873beb7-5857-4685-be1f-d57550cc96cc" xsi:nil="true"/>
-    <AssetId xmlns="4873beb7-5857-4685-be1f-d57550cc96cc">TP103431361</AssetId>
-    <TPClientViewer xmlns="4873beb7-5857-4685-be1f-d57550cc96cc" xsi:nil="true"/>
-    <DSATActionTaken xmlns="4873beb7-5857-4685-be1f-d57550cc96cc" xsi:nil="true"/>
-    <APEditor xmlns="4873beb7-5857-4685-be1f-d57550cc96cc">
-      <UserInfo>
-        <DisplayName/>
-        <AccountId xsi:nil="true"/>
-        <AccountType/>
-      </UserInfo>
-    </APEditor>
-    <TPInstallLocation xmlns="4873beb7-5857-4685-be1f-d57550cc96cc" xsi:nil="true"/>
-    <OOCacheId xmlns="4873beb7-5857-4685-be1f-d57550cc96cc" xsi:nil="true"/>
-    <IsDeleted xmlns="4873beb7-5857-4685-be1f-d57550cc96cc">false</IsDeleted>
-    <PublishTargets xmlns="4873beb7-5857-4685-be1f-d57550cc96cc">OfficeOnlineVNext</PublishTargets>
-    <ApprovalLog xmlns="4873beb7-5857-4685-be1f-d57550cc96cc" xsi:nil="true"/>
-    <BugNumber xmlns="4873beb7-5857-4685-be1f-d57550cc96cc" xsi:nil="true"/>
-    <CrawlForDependencies xmlns="4873beb7-5857-4685-be1f-d57550cc96cc">false</CrawlForDependencies>
-    <InternalTagsTaxHTField0 xmlns="4873beb7-5857-4685-be1f-d57550cc96cc">
-      <Terms xmlns="http://schemas.microsoft.com/office/infopath/2007/PartnerControls"/>
-    </InternalTagsTaxHTField0>
-    <LastHandOff xmlns="4873beb7-5857-4685-be1f-d57550cc96cc" xsi:nil="true"/>
-    <Milestone xmlns="4873beb7-5857-4685-be1f-d57550cc96cc" xsi:nil="true"/>
-    <OriginalRelease xmlns="4873beb7-5857-4685-be1f-d57550cc96cc">15</OriginalRelease>
-    <RecommendationsModifier xmlns="4873beb7-5857-4685-be1f-d57550cc96cc" xsi:nil="true"/>
-    <ScenarioTagsTaxHTField0 xmlns="4873beb7-5857-4685-be1f-d57550cc96cc">
-      <Terms xmlns="http://schemas.microsoft.com/office/infopath/2007/PartnerControls"/>
-    </ScenarioTagsTaxHTField0>
-    <UANotes xmlns="4873beb7-5857-4685-be1f-d57550cc96cc" xsi:nil="true"/>
-  </documentManagement>
-</p:properties>
-</file>
-
-<file path=customXml/item3.xml><?xml version="1.0" encoding="utf-8"?>
 <ct:contentTypeSchema xmlns:ct="http://schemas.microsoft.com/office/2006/metadata/contentType" xmlns:ma="http://schemas.microsoft.com/office/2006/metadata/properties/metaAttributes" ct:_="" ma:_="" ma:contentTypeName="TemplateFile" ma:contentTypeID="0x0101006EDDDB5EE6D98C44930B742096920B300400F5B6D36B3EF94B4E9A635CDF2A18F5B8" ma:contentTypeVersion="72" ma:contentTypeDescription="Create a new document." ma:contentTypeScope="" ma:versionID="a23e56308344d904b51738559c3d67c9">
   <xsd:schema xmlns:xsd="http://www.w3.org/2001/XMLSchema" xmlns:xs="http://www.w3.org/2001/XMLSchema" xmlns:p="http://schemas.microsoft.com/office/2006/metadata/properties" xmlns:ns2="4873beb7-5857-4685-be1f-d57550cc96cc" targetNamespace="http://schemas.microsoft.com/office/2006/metadata/properties" ma:root="true" ma:fieldsID="cd0908cc4600e77bf5da051303e00c8d" ns2:_="">
     <xsd:import namespace="4873beb7-5857-4685-be1f-d57550cc96cc"/>
@@ -11391,10 +11195,155 @@
 </ct:contentTypeSchema>
 </file>
 
+<file path=customXml/item2.xml><?xml version="1.0" encoding="utf-8"?>
+<p:properties xmlns:p="http://schemas.microsoft.com/office/2006/metadata/properties" xmlns:xsi="http://www.w3.org/2001/XMLSchema-instance" xmlns:pc="http://schemas.microsoft.com/office/infopath/2007/PartnerControls">
+  <documentManagement>
+    <APDescription xmlns="4873beb7-5857-4685-be1f-d57550cc96cc" xsi:nil="true"/>
+    <AssetExpire xmlns="4873beb7-5857-4685-be1f-d57550cc96cc">2029-01-01T08:00:00+00:00</AssetExpire>
+    <CampaignTagsTaxHTField0 xmlns="4873beb7-5857-4685-be1f-d57550cc96cc">
+      <Terms xmlns="http://schemas.microsoft.com/office/infopath/2007/PartnerControls"/>
+    </CampaignTagsTaxHTField0>
+    <IntlLangReviewDate xmlns="4873beb7-5857-4685-be1f-d57550cc96cc" xsi:nil="true"/>
+    <TPFriendlyName xmlns="4873beb7-5857-4685-be1f-d57550cc96cc" xsi:nil="true"/>
+    <IntlLangReview xmlns="4873beb7-5857-4685-be1f-d57550cc96cc">false</IntlLangReview>
+    <LocLastLocAttemptVersionLookup xmlns="4873beb7-5857-4685-be1f-d57550cc96cc">855024</LocLastLocAttemptVersionLookup>
+    <PolicheckWords xmlns="4873beb7-5857-4685-be1f-d57550cc96cc" xsi:nil="true"/>
+    <SubmitterId xmlns="4873beb7-5857-4685-be1f-d57550cc96cc" xsi:nil="true"/>
+    <AcquiredFrom xmlns="4873beb7-5857-4685-be1f-d57550cc96cc">Internal MS</AcquiredFrom>
+    <EditorialStatus xmlns="4873beb7-5857-4685-be1f-d57550cc96cc">Complete</EditorialStatus>
+    <Markets xmlns="4873beb7-5857-4685-be1f-d57550cc96cc"/>
+    <OriginAsset xmlns="4873beb7-5857-4685-be1f-d57550cc96cc" xsi:nil="true"/>
+    <AssetStart xmlns="4873beb7-5857-4685-be1f-d57550cc96cc">2012-08-31T08:50:00+00:00</AssetStart>
+    <FriendlyTitle xmlns="4873beb7-5857-4685-be1f-d57550cc96cc" xsi:nil="true"/>
+    <MarketSpecific xmlns="4873beb7-5857-4685-be1f-d57550cc96cc">false</MarketSpecific>
+    <TPNamespace xmlns="4873beb7-5857-4685-be1f-d57550cc96cc" xsi:nil="true"/>
+    <PublishStatusLookup xmlns="4873beb7-5857-4685-be1f-d57550cc96cc">
+      <Value>1616423</Value>
+    </PublishStatusLookup>
+    <APAuthor xmlns="4873beb7-5857-4685-be1f-d57550cc96cc">
+      <UserInfo>
+        <DisplayName>REDMOND\kristaa</DisplayName>
+        <AccountId>136</AccountId>
+        <AccountType/>
+      </UserInfo>
+    </APAuthor>
+    <TPCommandLine xmlns="4873beb7-5857-4685-be1f-d57550cc96cc" xsi:nil="true"/>
+    <IntlLangReviewer xmlns="4873beb7-5857-4685-be1f-d57550cc96cc" xsi:nil="true"/>
+    <OpenTemplate xmlns="4873beb7-5857-4685-be1f-d57550cc96cc">true</OpenTemplate>
+    <CSXSubmissionDate xmlns="4873beb7-5857-4685-be1f-d57550cc96cc" xsi:nil="true"/>
+    <TaxCatchAll xmlns="4873beb7-5857-4685-be1f-d57550cc96cc"/>
+    <Manager xmlns="4873beb7-5857-4685-be1f-d57550cc96cc" xsi:nil="true"/>
+    <NumericId xmlns="4873beb7-5857-4685-be1f-d57550cc96cc" xsi:nil="true"/>
+    <ParentAssetId xmlns="4873beb7-5857-4685-be1f-d57550cc96cc" xsi:nil="true"/>
+    <OriginalSourceMarket xmlns="4873beb7-5857-4685-be1f-d57550cc96cc" xsi:nil="true"/>
+    <ApprovalStatus xmlns="4873beb7-5857-4685-be1f-d57550cc96cc">InProgress</ApprovalStatus>
+    <TPComponent xmlns="4873beb7-5857-4685-be1f-d57550cc96cc" xsi:nil="true"/>
+    <EditorialTags xmlns="4873beb7-5857-4685-be1f-d57550cc96cc" xsi:nil="true"/>
+    <TPExecutable xmlns="4873beb7-5857-4685-be1f-d57550cc96cc" xsi:nil="true"/>
+    <TPLaunchHelpLink xmlns="4873beb7-5857-4685-be1f-d57550cc96cc" xsi:nil="true"/>
+    <LocComments xmlns="4873beb7-5857-4685-be1f-d57550cc96cc" xsi:nil="true"/>
+    <LocRecommendedHandoff xmlns="4873beb7-5857-4685-be1f-d57550cc96cc" xsi:nil="true"/>
+    <SourceTitle xmlns="4873beb7-5857-4685-be1f-d57550cc96cc" xsi:nil="true"/>
+    <CSXUpdate xmlns="4873beb7-5857-4685-be1f-d57550cc96cc">false</CSXUpdate>
+    <IntlLocPriority xmlns="4873beb7-5857-4685-be1f-d57550cc96cc" xsi:nil="true"/>
+    <UAProjectedTotalWords xmlns="4873beb7-5857-4685-be1f-d57550cc96cc" xsi:nil="true"/>
+    <AssetType xmlns="4873beb7-5857-4685-be1f-d57550cc96cc">TP</AssetType>
+    <MachineTranslated xmlns="4873beb7-5857-4685-be1f-d57550cc96cc">false</MachineTranslated>
+    <OutputCachingOn xmlns="4873beb7-5857-4685-be1f-d57550cc96cc">false</OutputCachingOn>
+    <TemplateStatus xmlns="4873beb7-5857-4685-be1f-d57550cc96cc">Complete</TemplateStatus>
+    <IsSearchable xmlns="4873beb7-5857-4685-be1f-d57550cc96cc">true</IsSearchable>
+    <ContentItem xmlns="4873beb7-5857-4685-be1f-d57550cc96cc" xsi:nil="true"/>
+    <HandoffToMSDN xmlns="4873beb7-5857-4685-be1f-d57550cc96cc" xsi:nil="true"/>
+    <ShowIn xmlns="4873beb7-5857-4685-be1f-d57550cc96cc">Show everywhere</ShowIn>
+    <ThumbnailAssetId xmlns="4873beb7-5857-4685-be1f-d57550cc96cc" xsi:nil="true"/>
+    <UALocComments xmlns="4873beb7-5857-4685-be1f-d57550cc96cc" xsi:nil="true"/>
+    <UALocRecommendation xmlns="4873beb7-5857-4685-be1f-d57550cc96cc">Localize</UALocRecommendation>
+    <LastModifiedDateTime xmlns="4873beb7-5857-4685-be1f-d57550cc96cc" xsi:nil="true"/>
+    <LegacyData xmlns="4873beb7-5857-4685-be1f-d57550cc96cc" xsi:nil="true"/>
+    <LocManualTestRequired xmlns="4873beb7-5857-4685-be1f-d57550cc96cc">false</LocManualTestRequired>
+    <LocMarketGroupTiers2 xmlns="4873beb7-5857-4685-be1f-d57550cc96cc" xsi:nil="true"/>
+    <ClipArtFilename xmlns="4873beb7-5857-4685-be1f-d57550cc96cc" xsi:nil="true"/>
+    <TPApplication xmlns="4873beb7-5857-4685-be1f-d57550cc96cc" xsi:nil="true"/>
+    <CSXHash xmlns="4873beb7-5857-4685-be1f-d57550cc96cc" xsi:nil="true"/>
+    <DirectSourceMarket xmlns="4873beb7-5857-4685-be1f-d57550cc96cc" xsi:nil="true"/>
+    <PrimaryImageGen xmlns="4873beb7-5857-4685-be1f-d57550cc96cc">true</PrimaryImageGen>
+    <PlannedPubDate xmlns="4873beb7-5857-4685-be1f-d57550cc96cc" xsi:nil="true"/>
+    <CSXSubmissionMarket xmlns="4873beb7-5857-4685-be1f-d57550cc96cc" xsi:nil="true"/>
+    <Downloads xmlns="4873beb7-5857-4685-be1f-d57550cc96cc">0</Downloads>
+    <ArtSampleDocs xmlns="4873beb7-5857-4685-be1f-d57550cc96cc" xsi:nil="true"/>
+    <TrustLevel xmlns="4873beb7-5857-4685-be1f-d57550cc96cc">1 Microsoft Managed Content</TrustLevel>
+    <BlockPublish xmlns="4873beb7-5857-4685-be1f-d57550cc96cc">false</BlockPublish>
+    <TPLaunchHelpLinkType xmlns="4873beb7-5857-4685-be1f-d57550cc96cc">Template</TPLaunchHelpLinkType>
+    <LocalizationTagsTaxHTField0 xmlns="4873beb7-5857-4685-be1f-d57550cc96cc">
+      <Terms xmlns="http://schemas.microsoft.com/office/infopath/2007/PartnerControls"/>
+    </LocalizationTagsTaxHTField0>
+    <BusinessGroup xmlns="4873beb7-5857-4685-be1f-d57550cc96cc" xsi:nil="true"/>
+    <Providers xmlns="4873beb7-5857-4685-be1f-d57550cc96cc" xsi:nil="true"/>
+    <TemplateTemplateType xmlns="4873beb7-5857-4685-be1f-d57550cc96cc">PowerPoint Presentation Template</TemplateTemplateType>
+    <TimesCloned xmlns="4873beb7-5857-4685-be1f-d57550cc96cc" xsi:nil="true"/>
+    <TPAppVersion xmlns="4873beb7-5857-4685-be1f-d57550cc96cc" xsi:nil="true"/>
+    <VoteCount xmlns="4873beb7-5857-4685-be1f-d57550cc96cc" xsi:nil="true"/>
+    <AverageRating xmlns="4873beb7-5857-4685-be1f-d57550cc96cc" xsi:nil="true"/>
+    <FeatureTagsTaxHTField0 xmlns="4873beb7-5857-4685-be1f-d57550cc96cc">
+      <Terms xmlns="http://schemas.microsoft.com/office/infopath/2007/PartnerControls"/>
+    </FeatureTagsTaxHTField0>
+    <Provider xmlns="4873beb7-5857-4685-be1f-d57550cc96cc" xsi:nil="true"/>
+    <UACurrentWords xmlns="4873beb7-5857-4685-be1f-d57550cc96cc" xsi:nil="true"/>
+    <AssetId xmlns="4873beb7-5857-4685-be1f-d57550cc96cc">TP103431361</AssetId>
+    <TPClientViewer xmlns="4873beb7-5857-4685-be1f-d57550cc96cc" xsi:nil="true"/>
+    <DSATActionTaken xmlns="4873beb7-5857-4685-be1f-d57550cc96cc" xsi:nil="true"/>
+    <APEditor xmlns="4873beb7-5857-4685-be1f-d57550cc96cc">
+      <UserInfo>
+        <DisplayName/>
+        <AccountId xsi:nil="true"/>
+        <AccountType/>
+      </UserInfo>
+    </APEditor>
+    <TPInstallLocation xmlns="4873beb7-5857-4685-be1f-d57550cc96cc" xsi:nil="true"/>
+    <OOCacheId xmlns="4873beb7-5857-4685-be1f-d57550cc96cc" xsi:nil="true"/>
+    <IsDeleted xmlns="4873beb7-5857-4685-be1f-d57550cc96cc">false</IsDeleted>
+    <PublishTargets xmlns="4873beb7-5857-4685-be1f-d57550cc96cc">OfficeOnlineVNext</PublishTargets>
+    <ApprovalLog xmlns="4873beb7-5857-4685-be1f-d57550cc96cc" xsi:nil="true"/>
+    <BugNumber xmlns="4873beb7-5857-4685-be1f-d57550cc96cc" xsi:nil="true"/>
+    <CrawlForDependencies xmlns="4873beb7-5857-4685-be1f-d57550cc96cc">false</CrawlForDependencies>
+    <InternalTagsTaxHTField0 xmlns="4873beb7-5857-4685-be1f-d57550cc96cc">
+      <Terms xmlns="http://schemas.microsoft.com/office/infopath/2007/PartnerControls"/>
+    </InternalTagsTaxHTField0>
+    <LastHandOff xmlns="4873beb7-5857-4685-be1f-d57550cc96cc" xsi:nil="true"/>
+    <Milestone xmlns="4873beb7-5857-4685-be1f-d57550cc96cc" xsi:nil="true"/>
+    <OriginalRelease xmlns="4873beb7-5857-4685-be1f-d57550cc96cc">15</OriginalRelease>
+    <RecommendationsModifier xmlns="4873beb7-5857-4685-be1f-d57550cc96cc" xsi:nil="true"/>
+    <ScenarioTagsTaxHTField0 xmlns="4873beb7-5857-4685-be1f-d57550cc96cc">
+      <Terms xmlns="http://schemas.microsoft.com/office/infopath/2007/PartnerControls"/>
+    </ScenarioTagsTaxHTField0>
+    <UANotes xmlns="4873beb7-5857-4685-be1f-d57550cc96cc" xsi:nil="true"/>
+  </documentManagement>
+</p:properties>
+</file>
+
+<file path=customXml/item3.xml><?xml version="1.0" encoding="utf-8"?>
+<?mso-contentType ?>
+<FormTemplates xmlns="http://schemas.microsoft.com/sharepoint/v3/contenttype/forms">
+  <Display>DocumentLibraryForm</Display>
+  <Edit>AssetEditForm</Edit>
+  <New>DocumentLibraryForm</New>
+</FormTemplates>
+</file>
+
 <file path=customXml/itemProps1.xml><?xml version="1.0" encoding="utf-8"?>
-<ds:datastoreItem xmlns:ds="http://schemas.openxmlformats.org/officeDocument/2006/customXml" ds:itemID="{561E720F-F05D-4536-9C34-0CFCED65D3B7}">
+<ds:datastoreItem xmlns:ds="http://schemas.openxmlformats.org/officeDocument/2006/customXml" ds:itemID="{28C8B9CA-0273-4370-889A-FC05DA5C2FA5}">
   <ds:schemaRefs>
-    <ds:schemaRef ds:uri="http://schemas.microsoft.com/sharepoint/v3/contenttype/forms"/>
+    <ds:schemaRef ds:uri="http://schemas.microsoft.com/office/2006/metadata/contentType"/>
+    <ds:schemaRef ds:uri="http://schemas.microsoft.com/office/2006/metadata/properties/metaAttributes"/>
+    <ds:schemaRef ds:uri="http://www.w3.org/2001/XMLSchema"/>
+    <ds:schemaRef ds:uri="http://schemas.microsoft.com/office/2006/metadata/properties"/>
+    <ds:schemaRef ds:uri="4873beb7-5857-4685-be1f-d57550cc96cc"/>
+    <ds:schemaRef ds:uri="http://schemas.microsoft.com/office/2006/documentManagement/types"/>
+    <ds:schemaRef ds:uri="http://schemas.microsoft.com/office/infopath/2007/PartnerControls"/>
+    <ds:schemaRef ds:uri="http://schemas.openxmlformats.org/package/2006/metadata/core-properties"/>
+    <ds:schemaRef ds:uri="http://purl.org/dc/elements/1.1/"/>
+    <ds:schemaRef ds:uri="http://purl.org/dc/terms/"/>
+    <ds:schemaRef ds:uri="http://schemas.microsoft.com/internal/obd"/>
   </ds:schemaRefs>
 </ds:datastoreItem>
 </file>
@@ -11416,19 +11365,9 @@
 </file>
 
 <file path=customXml/itemProps3.xml><?xml version="1.0" encoding="utf-8"?>
-<ds:datastoreItem xmlns:ds="http://schemas.openxmlformats.org/officeDocument/2006/customXml" ds:itemID="{28C8B9CA-0273-4370-889A-FC05DA5C2FA5}">
+<ds:datastoreItem xmlns:ds="http://schemas.openxmlformats.org/officeDocument/2006/customXml" ds:itemID="{561E720F-F05D-4536-9C34-0CFCED65D3B7}">
   <ds:schemaRefs>
-    <ds:schemaRef ds:uri="http://schemas.microsoft.com/office/2006/metadata/contentType"/>
-    <ds:schemaRef ds:uri="http://schemas.microsoft.com/office/2006/metadata/properties/metaAttributes"/>
-    <ds:schemaRef ds:uri="http://www.w3.org/2001/XMLSchema"/>
-    <ds:schemaRef ds:uri="http://schemas.microsoft.com/office/2006/metadata/properties"/>
-    <ds:schemaRef ds:uri="4873beb7-5857-4685-be1f-d57550cc96cc"/>
-    <ds:schemaRef ds:uri="http://schemas.microsoft.com/office/2006/documentManagement/types"/>
-    <ds:schemaRef ds:uri="http://schemas.microsoft.com/office/infopath/2007/PartnerControls"/>
-    <ds:schemaRef ds:uri="http://schemas.openxmlformats.org/package/2006/metadata/core-properties"/>
-    <ds:schemaRef ds:uri="http://purl.org/dc/elements/1.1/"/>
-    <ds:schemaRef ds:uri="http://purl.org/dc/terms/"/>
-    <ds:schemaRef ds:uri="http://schemas.microsoft.com/internal/obd"/>
+    <ds:schemaRef ds:uri="http://schemas.microsoft.com/sharepoint/v3/contenttype/forms"/>
   </ds:schemaRefs>
 </ds:datastoreItem>
 </file>
</xml_diff>